<commit_message>
Fix section divider content overlap and portable corpus layouts
</commit_message>
<xml_diff>
--- a/templates/modern-template.pptx
+++ b/templates/modern-template.pptx
@@ -1015,8 +1015,8 @@
         </p:nvSpPr>
         <p:spPr>
           <a:xfrm>
-            <a:off x="838200" y="3886200"/>
-            <a:ext cx="10515600" cy="2286000"/>
+            <a:off x="838200" y="4700000"/>
+            <a:ext cx="10515600" cy="2057400"/>
           </a:xfrm>
           <a:prstGeom prst="rect">
             <a:avLst/>
@@ -1026,7 +1026,15 @@
           <a:bodyPr>
             <a:normAutofit/>
           </a:bodyPr>
-          <a:lstStyle/>
+          <a:lstStyle>
+            <a:lvl1pPr>
+              <a:defRPr sz="1800">
+                <a:solidFill>
+                  <a:schemeClr val="bg1"/>
+                </a:solidFill>
+              </a:defRPr>
+            </a:lvl1pPr>
+          </a:lstStyle>
           <a:p>
             <a:endParaRPr lang="en-US"/>
           </a:p>

</xml_diff>

<commit_message>
fix(templates): separate modern divider number and title regions
</commit_message>
<xml_diff>
--- a/templates/modern-template.pptx
+++ b/templates/modern-template.pptx
@@ -977,8 +977,8 @@
         </p:nvSpPr>
         <p:spPr>
           <a:xfrm>
-            <a:off x="1450428" y="990601"/>
-            <a:ext cx="9145991" cy="3630384"/>
+            <a:off x="1450428" y="2352408"/>
+            <a:ext cx="9145991" cy="2268577"/>
           </a:xfrm>
         </p:spPr>
         <p:txBody>
@@ -1053,11 +1053,11 @@
         <p:spPr>
           <a:xfrm>
             <a:off x="7886700" y="572408"/>
-            <a:ext cx="3182938" cy="3417887"/>
+            <a:ext cx="3182938" cy="1600000"/>
           </a:xfrm>
         </p:spPr>
         <p:txBody>
-          <a:bodyPr/>
+          <a:bodyPr anchor="t"/>
           <a:lstStyle>
             <a:lvl1pPr marL="11113" indent="-11113">
               <a:buNone/>

</xml_diff>

<commit_message>
fix(templates): remove isolated Closing connector and retain native content
</commit_message>
<xml_diff>
--- a/templates/modern-template.pptx
+++ b/templates/modern-template.pptx
@@ -1551,45 +1551,6 @@
           </a:p>
         </p:txBody>
       </p:sp>
-      <p:cxnSp>
-        <p:nvCxnSpPr>
-          <p:cNvPr id="11" name="Straight Connector 10">
-            <a:extLst>
-              <a:ext uri="{FF2B5EF4-FFF2-40B4-BE49-F238E27FC236}">
-                <a16:creationId xmlns:a16="http://schemas.microsoft.com/office/drawing/2014/main" id="{BB055BD5-F132-7EB0-787E-04988310DC8B}"/>
-              </a:ext>
-            </a:extLst>
-          </p:cNvPr>
-          <p:cNvCxnSpPr>
-            <a:cxnSpLocks/>
-          </p:cNvCxnSpPr>
-          <p:nvPr/>
-        </p:nvCxnSpPr>
-        <p:spPr>
-          <a:xfrm>
-            <a:off x="4985657" y="3300000"/>
-            <a:ext cx="0" cy="320000"/>
-          </a:xfrm>
-          <a:prstGeom prst="line">
-            <a:avLst/>
-          </a:prstGeom>
-          <a:ln w="19050"/>
-        </p:spPr>
-        <p:style>
-          <a:lnRef idx="1">
-            <a:schemeClr val="dk1"/>
-          </a:lnRef>
-          <a:fillRef idx="0">
-            <a:schemeClr val="dk1"/>
-          </a:fillRef>
-          <a:effectRef idx="0">
-            <a:schemeClr val="dk1"/>
-          </a:effectRef>
-          <a:fontRef idx="minor">
-            <a:schemeClr val="tx1"/>
-          </a:fontRef>
-        </p:style>
-      </p:cxnSp>
     </p:spTree>
     <p:extLst>
       <p:ext uri="{BB962C8B-B14F-4D97-AF65-F5344CB8AC3E}">

</xml_diff>

<commit_message>
fix(template): improve modern closing composition and artwork
</commit_message>
<xml_diff>
--- a/templates/modern-template.pptx
+++ b/templates/modern-template.pptx
@@ -1458,7 +1458,7 @@
         <p:spPr>
           <a:xfrm>
             <a:off x="4830857" y="1500000"/>
-            <a:ext cx="7014009" cy="1800000"/>
+            <a:ext cx="6500000" cy="1800000"/>
           </a:xfrm>
         </p:spPr>
         <p:txBody>
@@ -1499,12 +1499,12 @@
         </p:nvSpPr>
         <p:spPr>
           <a:xfrm>
-            <a:off x="4830857" y="3800000"/>
-            <a:ext cx="7014009" cy="1200000"/>
+            <a:off x="4830857" y="3450000"/>
+            <a:ext cx="4800000" cy="1200000"/>
           </a:xfrm>
         </p:spPr>
         <p:txBody>
-          <a:bodyPr anchor="b">
+          <a:bodyPr anchor="t">
             <a:noAutofit/>
           </a:bodyPr>
           <a:lstStyle>

</xml_diff>

<commit_message>
fix(template): align modern section tagline with title
</commit_message>
<xml_diff>
--- a/templates/modern-template.pptx
+++ b/templates/modern-template.pptx
@@ -1015,8 +1015,8 @@
         </p:nvSpPr>
         <p:spPr>
           <a:xfrm>
-            <a:off x="838200" y="4700000"/>
-            <a:ext cx="10515600" cy="2057400"/>
+            <a:off x="1450428" y="4700000"/>
+            <a:ext cx="9903372" cy="2057400"/>
           </a:xfrm>
           <a:prstGeom prst="rect">
             <a:avLst/>

</xml_diff>

<commit_message>
fix(fonts): preserve native Lora metrics and embedded rendering
Beads: go-slide-creator-3qzo4.98, go-slide-creator-3qzo4.101
</commit_message>
<xml_diff>
--- a/templates/modern-template.pptx
+++ b/templates/modern-template.pptx
@@ -1,6 +1,6 @@
 
 <file path=ppt/presentation.xml><?xml version="1.0" encoding="utf-8"?>
-<p:presentation xmlns:a="http://schemas.openxmlformats.org/drawingml/2006/main" xmlns:r="http://schemas.openxmlformats.org/officeDocument/2006/relationships" xmlns:p="http://schemas.openxmlformats.org/presentationml/2006/main" saveSubsetFonts="1">
+<p:presentation xmlns:a="http://schemas.openxmlformats.org/drawingml/2006/main" xmlns:r="http://schemas.openxmlformats.org/officeDocument/2006/relationships" xmlns:p="http://schemas.openxmlformats.org/presentationml/2006/main" saveSubsetFonts="0" embedTrueTypeFonts="1">
   <p:sldMasterIdLst>
     <p:sldMasterId id="2147483826" r:id="rId4"/>
   </p:sldMasterIdLst>
@@ -18,6 +18,13 @@
   </p:sldIdLst>
   <p:sldSz cx="12192000" cy="6858000"/>
   <p:notesSz cx="6858000" cy="9144000"/>
+  <p:embeddedFontLst>
+    <p:embeddedFont>
+      <p:font typeface="Lora" charset="1"/>
+      <p:regular r:id="rIdLoraRegular"/>
+      <p:bold r:id="rIdLoraBold"/>
+    </p:embeddedFont>
+  </p:embeddedFontLst>
   <p:defaultTextStyle>
     <a:defPPr>
       <a:defRPr lang="en-US"/>

</xml_diff>

<commit_message>
fix(templates): balance native modern closing composition
</commit_message>
<xml_diff>
--- a/templates/modern-template.pptx
+++ b/templates/modern-template.pptx
@@ -1429,6 +1429,7 @@
         </p:nvPicPr>
         <p:blipFill>
           <a:blip r:embed="rId2" cstate="print">
+            <a:alphaModFix amt="15000"/>
             <a:extLst>
               <a:ext uri="{28A0092B-C50C-407E-A947-70E740481C1C}">
                 <a14:useLocalDpi xmlns:a14="http://schemas.microsoft.com/office/drawing/2010/main"/>
@@ -1466,8 +1467,8 @@
         </p:nvSpPr>
         <p:spPr>
           <a:xfrm>
-            <a:off x="4830857" y="1500000"/>
-            <a:ext cx="6500000" cy="1800000"/>
+            <a:off x="1000000" y="1500000"/>
+            <a:ext cx="10330857" cy="1800000"/>
           </a:xfrm>
         </p:spPr>
         <p:txBody>
@@ -1508,7 +1509,7 @@
         </p:nvSpPr>
         <p:spPr>
           <a:xfrm>
-            <a:off x="4830857" y="3450000"/>
+            <a:off x="1000000" y="3450000"/>
             <a:ext cx="4800000" cy="1200000"/>
           </a:xfrm>
         </p:spPr>

</xml_diff>

<commit_message>
fix: preserve native Poppins metrics and portable embedding
Refresh all local and portability preview provenance, retain original Light/Italic assets and native synthetic-bold semantics, and document safe sequential preview generation.

Beads: go-slide-creator-3qzo4.103, go-slide-creator-3qzo4.106, go-slide-creator-3qzo4.107, go-slide-creator-3qzo4.108
</commit_message>
<xml_diff>
--- a/templates/modern-template.pptx
+++ b/templates/modern-template.pptx
@@ -23,6 +23,11 @@
       <p:font typeface="Lora" charset="1"/>
       <p:regular r:id="rIdLoraRegular"/>
       <p:bold r:id="rIdLoraBold"/>
+    </p:embeddedFont>
+    <p:embeddedFont>
+      <p:font typeface="Poppins Light" charset="1"/>
+      <p:regular r:id="rIdPoppinsLight"/>
+      <p:italic r:id="rIdPoppinsLightItalic"/>
     </p:embeddedFont>
   </p:embeddedFontLst>
   <p:defaultTextStyle>

</xml_diff>

<commit_message>
Repair modern native content typography and strengthen inheritance guards
</commit_message>
<xml_diff>
--- a/templates/modern-template.pptx
+++ b/templates/modern-template.pptx
@@ -1149,14 +1149,17 @@
         </p:nvSpPr>
         <p:spPr>
           <a:xfrm>
-            <a:off x="860893" y="907303"/>
-            <a:ext cx="10465073" cy="1132258"/>
+            <a:off x="860893" y="647303"/>
+            <a:ext cx="10465073" cy="1532258"/>
           </a:xfrm>
         </p:spPr>
         <p:txBody>
-          <a:bodyPr/>
+          <a:bodyPr anchor="b"/>
           <a:lstStyle>
             <a:lvl1pPr>
+              <a:lnSpc>
+                <a:spcPct val="100000"/>
+              </a:lnSpc>
               <a:defRPr>
                 <a:latin typeface="+mj-lt"/>
               </a:defRPr>
@@ -1189,7 +1192,33 @@
         </p:spPr>
         <p:txBody>
           <a:bodyPr/>
-          <a:lstStyle/>
+          <a:lstStyle>
+            <a:lvl1pPr>
+              <a:lnSpc>
+                <a:spcPct val="110000"/>
+              </a:lnSpc>
+            </a:lvl1pPr>
+            <a:lvl2pPr marL="565200">
+              <a:lnSpc>
+                <a:spcPct val="110000"/>
+              </a:lnSpc>
+            </a:lvl2pPr>
+            <a:lvl3pPr>
+              <a:lnSpc>
+                <a:spcPct val="110000"/>
+              </a:lnSpc>
+            </a:lvl3pPr>
+            <a:lvl4pPr>
+              <a:lnSpc>
+                <a:spcPct val="110000"/>
+              </a:lnSpc>
+            </a:lvl4pPr>
+            <a:lvl5pPr>
+              <a:lnSpc>
+                <a:spcPct val="110000"/>
+              </a:lnSpc>
+            </a:lvl5pPr>
+          </a:lstStyle>
           <a:p>
             <a:pPr lvl="0"/>
             <a:r>
@@ -1231,7 +1260,33 @@
         </p:spPr>
         <p:txBody>
           <a:bodyPr/>
-          <a:lstStyle/>
+          <a:lstStyle>
+            <a:lvl1pPr>
+              <a:lnSpc>
+                <a:spcPct val="110000"/>
+              </a:lnSpc>
+            </a:lvl1pPr>
+            <a:lvl2pPr marL="565200">
+              <a:lnSpc>
+                <a:spcPct val="110000"/>
+              </a:lnSpc>
+            </a:lvl2pPr>
+            <a:lvl3pPr>
+              <a:lnSpc>
+                <a:spcPct val="110000"/>
+              </a:lnSpc>
+            </a:lvl3pPr>
+            <a:lvl4pPr>
+              <a:lnSpc>
+                <a:spcPct val="110000"/>
+              </a:lnSpc>
+            </a:lvl4pPr>
+            <a:lvl5pPr>
+              <a:lnSpc>
+                <a:spcPct val="110000"/>
+              </a:lnSpc>
+            </a:lvl5pPr>
+          </a:lstStyle>
           <a:p>
             <a:pPr lvl="0"/>
             <a:r>
@@ -1298,14 +1353,17 @@
         </p:nvSpPr>
         <p:spPr>
           <a:xfrm>
-            <a:off x="860893" y="907303"/>
-            <a:ext cx="10465073" cy="1132258"/>
+            <a:off x="860893" y="647303"/>
+            <a:ext cx="10465073" cy="1532258"/>
           </a:xfrm>
         </p:spPr>
         <p:txBody>
-          <a:bodyPr/>
+          <a:bodyPr anchor="b"/>
           <a:lstStyle>
             <a:lvl1pPr>
+              <a:lnSpc>
+                <a:spcPct val="100000"/>
+              </a:lnSpc>
               <a:defRPr>
                 <a:latin typeface="+mj-lt"/>
               </a:defRPr>
@@ -1344,7 +1402,33 @@
         </p:spPr>
         <p:txBody>
           <a:bodyPr/>
-          <a:lstStyle/>
+          <a:lstStyle>
+            <a:lvl1pPr>
+              <a:lnSpc>
+                <a:spcPct val="110000"/>
+              </a:lnSpc>
+            </a:lvl1pPr>
+            <a:lvl2pPr>
+              <a:lnSpc>
+                <a:spcPct val="110000"/>
+              </a:lnSpc>
+            </a:lvl2pPr>
+            <a:lvl3pPr>
+              <a:lnSpc>
+                <a:spcPct val="110000"/>
+              </a:lnSpc>
+            </a:lvl3pPr>
+            <a:lvl4pPr>
+              <a:lnSpc>
+                <a:spcPct val="110000"/>
+              </a:lnSpc>
+            </a:lvl4pPr>
+            <a:lvl5pPr>
+              <a:lnSpc>
+                <a:spcPct val="110000"/>
+              </a:lnSpc>
+            </a:lvl5pPr>
+          </a:lstStyle>
           <a:p>
             <a:pPr lvl="0"/>
             <a:r>

</xml_diff>

<commit_message>
fix(templates): modern-template content titles share one baseline (go-slide-creator-kyk01)
One Content, Two Content and Blank + Title now use the same title frame:
x 0.94in, y 0.55in, 11.45 x 1.68in, bottom-anchored, 100% leading. The
reviewed 1.68in multiline frame of the content layouts kept its size and
anchor and moved up 0.15in so its bottom edge meets Blank + Title's old
bottom edge (2.23in): pattern canvases (TitleBottom) are unchanged, so no
TestSchemaMaximaStayReadable pin moves, and content-slide bodies keep
their frames (title/body clearance grows from 0.21in to 0.36in).

modern-template leaves the conformance allow-list (now empty) and the
rendered-title cross-template test no longer skips it.
modern_typography_test pinned the content title's old y (647303), which
encoded the inconsistency; it now pins 507303. Size, anchor and leading
pins are unchanged.

Co-Authored-By: Claude Opus 5.5 <noreply@anthropic.com>
</commit_message>
<xml_diff>
--- a/templates/modern-template.pptx
+++ b/templates/modern-template.pptx
@@ -1149,7 +1149,7 @@
         </p:nvSpPr>
         <p:spPr>
           <a:xfrm>
-            <a:off x="860893" y="647303"/>
+            <a:off x="860893" y="507303"/>
             <a:ext cx="10465073" cy="1532258"/>
           </a:xfrm>
         </p:spPr>
@@ -1353,7 +1353,7 @@
         </p:nvSpPr>
         <p:spPr>
           <a:xfrm>
-            <a:off x="860893" y="647303"/>
+            <a:off x="860893" y="507303"/>
             <a:ext cx="10465073" cy="1532258"/>
           </a:xfrm>
         </p:spPr>
@@ -1717,14 +1717,17 @@
         </p:nvSpPr>
         <p:spPr>
           <a:xfrm>
-            <a:off x="860893" y="907303"/>
-            <a:ext cx="10465073" cy="1132258"/>
+            <a:off x="860893" y="507303"/>
+            <a:ext cx="10465073" cy="1532258"/>
           </a:xfrm>
         </p:spPr>
         <p:txBody>
-          <a:bodyPr/>
+          <a:bodyPr anchor="b"/>
           <a:lstStyle>
             <a:lvl1pPr>
+              <a:lnSpc>
+                <a:spcPct val="100000"/>
+              </a:lnSpc>
               <a:defRPr>
                 <a:latin typeface="+mj-lt"/>
               </a:defRPr>

</xml_diff>